<commit_message>
rasch: thin-evidence items are provisional, not red
An item with fewer than 5 responses on the minority side (RASCH.THIN)
has a fit statistic that is a mean over a handful of cells. If its fit
would be flagged, the pill is grey, the reading says provisional with
the count, and the Wright map draws a hollow dashed bar instead of red.
Items only. In the badge demo this takes 'stand up an NDC server'
(2 of 23) off the red list, leaving the campfire skill as the one
misfit — which is the demo's story.

Intro, manual, schema and deck updated to match.

Co-Authored-By: Claude Opus 5 <noreply@anthropic.com>
Claude-Session: https://claude.ai/code/session_01UeeGkn7YGfwwdSWPETtcSm
</commit_message>
<xml_diff>
--- a/tools/rcn-rasch-intro.pptx
+++ b/tools/rcn-rasch-intro.pptx
@@ -16135,11 +16135,12 @@
           <a:prstGeom prst="rect">
             <a:avLst/>
           </a:prstGeom>
-          <a:solidFill>
-            <a:srgbClr val="DC2626"/>
-          </a:solidFill>
-          <a:ln>
-            <a:noFill/>
+          <a:noFill/>
+          <a:ln w="15240">
+            <a:solidFill>
+              <a:srgbClr val="B45309"/>
+            </a:solidFill>
+            <a:prstDash val="sysDash"/>
           </a:ln>
           <a:effectLst/>
         </p:spPr>
@@ -16174,7 +16175,7 @@
         <p:spPr>
           <a:xfrm>
             <a:off x="4599432" y="2883052"/>
-            <a:ext cx="2926080" cy="182880"/>
+            <a:ext cx="3108960" cy="182880"/>
           </a:xfrm>
           <a:prstGeom prst="rect">
             <a:avLst/>
@@ -16189,13 +16190,13 @@
           <a:p>
             <a:pPr algn="l"/>
             <a:r>
-              <a:rPr sz="800" b="1">
-                <a:solidFill>
-                  <a:srgbClr val="DC2626"/>
-                </a:solidFill>
-                <a:latin typeface="Calibri"/>
-              </a:rPr>
-              <a:t>stand up an NDC server   misfit</a:t>
+              <a:rPr sz="800" b="0">
+                <a:solidFill>
+                  <a:srgbClr val="94A3B8"/>
+                </a:solidFill>
+                <a:latin typeface="Calibri"/>
+              </a:rPr>
+              <a:t>stand up an NDC server   provisional — 2 on the minority side</a:t>
             </a:r>
           </a:p>
         </p:txBody>
@@ -17820,13 +17821,13 @@
               </a:lnSpc>
             </a:pPr>
             <a:r>
-              <a:rPr sz="1050" b="0" i="0">
+              <a:rPr sz="900" b="0" i="0">
                 <a:solidFill>
                   <a:srgbClr val="475569"/>
                 </a:solidFill>
                 <a:latin typeface="Calibri"/>
               </a:rPr>
-              <a:t>Is there a skill near every cluster of people, or are there gaps on the ruler? And is anything red?</a:t>
+              <a:t>Is there a skill near every cluster of people, or are there gaps on the ruler? And is anything red? A hollow bar is not red — it is too few responses to say.</a:t>
             </a:r>
           </a:p>
         </p:txBody>
@@ -18463,7 +18464,7 @@
             <a:r>
               <a:rPr sz="1150" b="1">
                 <a:solidFill>
-                  <a:srgbClr val="DC2626"/>
+                  <a:srgbClr val="94A3B8"/>
                 </a:solidFill>
                 <a:latin typeface="Calibri"/>
               </a:rPr>
@@ -18496,13 +18497,13 @@
           <a:p>
             <a:pPr algn="l"/>
             <a:r>
-              <a:rPr sz="1150" b="0">
-                <a:solidFill>
-                  <a:srgbClr val="475569"/>
-                </a:solidFill>
-                <a:latin typeface="Calibri"/>
-              </a:rPr>
-              <a:t>Two successes — outfit rests on almost nothing</a:t>
+              <a:rPr sz="1150" b="1">
+                <a:solidFill>
+                  <a:srgbClr val="94A3B8"/>
+                </a:solidFill>
+                <a:latin typeface="Calibri"/>
+              </a:rPr>
+              <a:t>Provisional — only 2 succeeded, too few to read fit</a:t>
             </a:r>
           </a:p>
         </p:txBody>
@@ -19441,9 +19442,9 @@
           <a:p>
             <a:pPr algn="r"/>
             <a:r>
-              <a:rPr sz="1150" b="0">
-                <a:solidFill>
-                  <a:srgbClr val="475569"/>
+              <a:rPr sz="1150" b="1">
+                <a:solidFill>
+                  <a:srgbClr val="94A3B8"/>
                 </a:solidFill>
                 <a:latin typeface="Calibri"/>
               </a:rPr>
@@ -19476,13 +19477,13 @@
           <a:p>
             <a:pPr algn="l"/>
             <a:r>
-              <a:rPr sz="1150" b="0">
-                <a:solidFill>
-                  <a:srgbClr val="475569"/>
-                </a:solidFill>
-                <a:latin typeface="Calibri"/>
-              </a:rPr>
-              <a:t>Behaves as expected</a:t>
+              <a:rPr sz="1150" b="1">
+                <a:solidFill>
+                  <a:srgbClr val="94A3B8"/>
+                </a:solidFill>
+                <a:latin typeface="Calibri"/>
+              </a:rPr>
+              <a:t>Provisional — only 4 failed, too few to read fit</a:t>
             </a:r>
           </a:p>
         </p:txBody>
@@ -19602,7 +19603,7 @@
                 </a:solidFill>
                 <a:latin typeface="Calibri"/>
               </a:rPr>
-              <a:t>Ten of twelve behave, one is flagged on thin evidence, one does not behave at all.</a:t>
+              <a:t>Eleven of twelve behave or sit on too little evidence to say. One does not, and it is not close.</a:t>
             </a:r>
           </a:p>
         </p:txBody>
@@ -19837,7 +19838,7 @@
         <p:spPr>
           <a:xfrm>
             <a:off x="777240" y="1965960"/>
-            <a:ext cx="5120640" cy="1920240"/>
+            <a:ext cx="5120640" cy="1737360"/>
           </a:xfrm>
           <a:prstGeom prst="rect">
             <a:avLst/>
@@ -19883,7 +19884,7 @@
         <p:spPr>
           <a:xfrm>
             <a:off x="777240" y="1965960"/>
-            <a:ext cx="50292" cy="1920240"/>
+            <a:ext cx="50292" cy="1737360"/>
           </a:xfrm>
           <a:prstGeom prst="rect">
             <a:avLst/>
@@ -19966,7 +19967,7 @@
         <p:spPr>
           <a:xfrm>
             <a:off x="1033271" y="2624328"/>
-            <a:ext cx="4663440" cy="1097280"/>
+            <a:ext cx="4663440" cy="914399"/>
           </a:xfrm>
           <a:prstGeom prst="rect">
             <a:avLst/>
@@ -20005,7 +20006,7 @@
         <p:spPr>
           <a:xfrm>
             <a:off x="6263640" y="1965960"/>
-            <a:ext cx="5120640" cy="1920240"/>
+            <a:ext cx="5120640" cy="1737360"/>
           </a:xfrm>
           <a:prstGeom prst="rect">
             <a:avLst/>
@@ -20051,7 +20052,7 @@
         <p:spPr>
           <a:xfrm>
             <a:off x="6263640" y="1965960"/>
-            <a:ext cx="50292" cy="1920240"/>
+            <a:ext cx="50292" cy="1737360"/>
           </a:xfrm>
           <a:prstGeom prst="rect">
             <a:avLst/>
@@ -20134,7 +20135,7 @@
         <p:spPr>
           <a:xfrm>
             <a:off x="6519672" y="2624328"/>
-            <a:ext cx="4663440" cy="1097280"/>
+            <a:ext cx="4663440" cy="914399"/>
           </a:xfrm>
           <a:prstGeom prst="rect">
             <a:avLst/>
@@ -20172,7 +20173,7 @@
         </p:nvSpPr>
         <p:spPr>
           <a:xfrm>
-            <a:off x="777240" y="4160520"/>
+            <a:off x="777240" y="3931920"/>
             <a:ext cx="1463040" cy="329184"/>
           </a:xfrm>
           <a:prstGeom prst="rect">
@@ -20207,7 +20208,7 @@
         </p:nvSpPr>
         <p:spPr>
           <a:xfrm>
-            <a:off x="2240280" y="4160520"/>
+            <a:off x="2240280" y="3931920"/>
             <a:ext cx="2011680" cy="329184"/>
           </a:xfrm>
           <a:prstGeom prst="rect">
@@ -20242,7 +20243,7 @@
         </p:nvSpPr>
         <p:spPr>
           <a:xfrm>
-            <a:off x="4251960" y="4160520"/>
+            <a:off x="4251960" y="3931920"/>
             <a:ext cx="7132320" cy="329184"/>
           </a:xfrm>
           <a:prstGeom prst="rect">
@@ -20277,7 +20278,7 @@
         </p:nvCxnSpPr>
         <p:spPr>
           <a:xfrm>
-            <a:off x="777240" y="4489704"/>
+            <a:off x="777240" y="4261104"/>
             <a:ext cx="10607040" cy="0"/>
           </a:xfrm>
           <a:prstGeom prst="line">
@@ -20312,7 +20313,7 @@
         </p:nvSpPr>
         <p:spPr>
           <a:xfrm>
-            <a:off x="777240" y="4489704"/>
+            <a:off x="777240" y="4261104"/>
             <a:ext cx="1463040" cy="329184"/>
           </a:xfrm>
           <a:prstGeom prst="rect">
@@ -20347,7 +20348,7 @@
         </p:nvSpPr>
         <p:spPr>
           <a:xfrm>
-            <a:off x="2240280" y="4489704"/>
+            <a:off x="2240280" y="4261104"/>
             <a:ext cx="2011680" cy="329184"/>
           </a:xfrm>
           <a:prstGeom prst="rect">
@@ -20382,7 +20383,7 @@
         </p:nvSpPr>
         <p:spPr>
           <a:xfrm>
-            <a:off x="4251960" y="4489704"/>
+            <a:off x="4251960" y="4261104"/>
             <a:ext cx="7132320" cy="329184"/>
           </a:xfrm>
           <a:prstGeom prst="rect">
@@ -20417,7 +20418,7 @@
         </p:nvCxnSpPr>
         <p:spPr>
           <a:xfrm>
-            <a:off x="777240" y="4818888"/>
+            <a:off x="777240" y="4590288"/>
             <a:ext cx="10607040" cy="0"/>
           </a:xfrm>
           <a:prstGeom prst="line">
@@ -20452,7 +20453,7 @@
         </p:nvSpPr>
         <p:spPr>
           <a:xfrm>
-            <a:off x="777240" y="4818888"/>
+            <a:off x="777240" y="4590288"/>
             <a:ext cx="1463040" cy="329184"/>
           </a:xfrm>
           <a:prstGeom prst="rect">
@@ -20487,7 +20488,7 @@
         </p:nvSpPr>
         <p:spPr>
           <a:xfrm>
-            <a:off x="2240280" y="4818888"/>
+            <a:off x="2240280" y="4590288"/>
             <a:ext cx="2011680" cy="329184"/>
           </a:xfrm>
           <a:prstGeom prst="rect">
@@ -20522,7 +20523,7 @@
         </p:nvSpPr>
         <p:spPr>
           <a:xfrm>
-            <a:off x="4251960" y="4818888"/>
+            <a:off x="4251960" y="4590288"/>
             <a:ext cx="7132320" cy="329184"/>
           </a:xfrm>
           <a:prstGeom prst="rect">
@@ -20557,7 +20558,7 @@
         </p:nvCxnSpPr>
         <p:spPr>
           <a:xfrm>
-            <a:off x="777240" y="5148072"/>
+            <a:off x="777240" y="4919472"/>
             <a:ext cx="10607040" cy="0"/>
           </a:xfrm>
           <a:prstGeom prst="line">
@@ -20592,7 +20593,7 @@
         </p:nvSpPr>
         <p:spPr>
           <a:xfrm>
-            <a:off x="777240" y="5148072"/>
+            <a:off x="777240" y="4919472"/>
             <a:ext cx="1463040" cy="329184"/>
           </a:xfrm>
           <a:prstGeom prst="rect">
@@ -20627,7 +20628,7 @@
         </p:nvSpPr>
         <p:spPr>
           <a:xfrm>
-            <a:off x="2240280" y="5148072"/>
+            <a:off x="2240280" y="4919472"/>
             <a:ext cx="2011680" cy="329184"/>
           </a:xfrm>
           <a:prstGeom prst="rect">
@@ -20662,7 +20663,7 @@
         </p:nvSpPr>
         <p:spPr>
           <a:xfrm>
-            <a:off x="4251960" y="5148072"/>
+            <a:off x="4251960" y="4919472"/>
             <a:ext cx="7132320" cy="329184"/>
           </a:xfrm>
           <a:prstGeom prst="rect">
@@ -20697,7 +20698,7 @@
         </p:nvCxnSpPr>
         <p:spPr>
           <a:xfrm>
-            <a:off x="777240" y="5477256"/>
+            <a:off x="777240" y="5248656"/>
             <a:ext cx="10607040" cy="0"/>
           </a:xfrm>
           <a:prstGeom prst="line">
@@ -20732,7 +20733,7 @@
         </p:nvSpPr>
         <p:spPr>
           <a:xfrm>
-            <a:off x="777240" y="5477256"/>
+            <a:off x="777240" y="5248656"/>
             <a:ext cx="1463040" cy="329184"/>
           </a:xfrm>
           <a:prstGeom prst="rect">
@@ -20767,7 +20768,7 @@
         </p:nvSpPr>
         <p:spPr>
           <a:xfrm>
-            <a:off x="2240280" y="5477256"/>
+            <a:off x="2240280" y="5248656"/>
             <a:ext cx="2011680" cy="329184"/>
           </a:xfrm>
           <a:prstGeom prst="rect">
@@ -20802,7 +20803,7 @@
         </p:nvSpPr>
         <p:spPr>
           <a:xfrm>
-            <a:off x="4251960" y="5477256"/>
+            <a:off x="4251960" y="5248656"/>
             <a:ext cx="7132320" cy="329184"/>
           </a:xfrm>
           <a:prstGeom prst="rect">
@@ -20837,7 +20838,7 @@
         </p:nvCxnSpPr>
         <p:spPr>
           <a:xfrm>
-            <a:off x="777240" y="5806440"/>
+            <a:off x="777240" y="5577840"/>
             <a:ext cx="10607040" cy="0"/>
           </a:xfrm>
           <a:prstGeom prst="line">
@@ -20872,8 +20873,148 @@
         </p:nvSpPr>
         <p:spPr>
           <a:xfrm>
-            <a:off x="777240" y="5806440"/>
-            <a:ext cx="10607040" cy="365760"/>
+            <a:off x="777240" y="5577840"/>
+            <a:ext cx="1463040" cy="329184"/>
+          </a:xfrm>
+          <a:prstGeom prst="rect">
+            <a:avLst/>
+          </a:prstGeom>
+          <a:noFill/>
+        </p:spPr>
+        <p:txBody>
+          <a:bodyPr wrap="square" lIns="54864" rIns="54864" tIns="27432" bIns="27432" anchor="ctr">
+            <a:spAutoFit/>
+          </a:bodyPr>
+          <a:lstStyle/>
+          <a:p>
+            <a:pPr algn="l"/>
+            <a:r>
+              <a:rPr sz="1200" b="1">
+                <a:solidFill>
+                  <a:srgbClr val="0F172A"/>
+                </a:solidFill>
+                <a:latin typeface="Calibri"/>
+              </a:rPr>
+              <a:t>thin evidence</a:t>
+            </a:r>
+          </a:p>
+        </p:txBody>
+      </p:sp>
+      <p:sp>
+        <p:nvSpPr>
+          <p:cNvPr id="33" name="TextBox 32"/>
+          <p:cNvSpPr txBox="1"/>
+          <p:nvPr/>
+        </p:nvSpPr>
+        <p:spPr>
+          <a:xfrm>
+            <a:off x="2240280" y="5577840"/>
+            <a:ext cx="2011680" cy="329184"/>
+          </a:xfrm>
+          <a:prstGeom prst="rect">
+            <a:avLst/>
+          </a:prstGeom>
+          <a:noFill/>
+        </p:spPr>
+        <p:txBody>
+          <a:bodyPr wrap="square" lIns="54864" rIns="54864" tIns="27432" bIns="27432" anchor="ctr">
+            <a:spAutoFit/>
+          </a:bodyPr>
+          <a:lstStyle/>
+          <a:p>
+            <a:pPr algn="l"/>
+            <a:r>
+              <a:rPr sz="1200" b="1">
+                <a:solidFill>
+                  <a:srgbClr val="94A3B8"/>
+                </a:solidFill>
+                <a:latin typeface="Calibri"/>
+              </a:rPr>
+              <a:t>grey</a:t>
+            </a:r>
+          </a:p>
+        </p:txBody>
+      </p:sp>
+      <p:sp>
+        <p:nvSpPr>
+          <p:cNvPr id="34" name="TextBox 33"/>
+          <p:cNvSpPr txBox="1"/>
+          <p:nvPr/>
+        </p:nvSpPr>
+        <p:spPr>
+          <a:xfrm>
+            <a:off x="4251960" y="5577840"/>
+            <a:ext cx="7132320" cy="329184"/>
+          </a:xfrm>
+          <a:prstGeom prst="rect">
+            <a:avLst/>
+          </a:prstGeom>
+          <a:noFill/>
+        </p:spPr>
+        <p:txBody>
+          <a:bodyPr wrap="square" lIns="54864" rIns="54864" tIns="27432" bIns="27432" anchor="ctr">
+            <a:spAutoFit/>
+          </a:bodyPr>
+          <a:lstStyle/>
+          <a:p>
+            <a:pPr algn="l"/>
+            <a:r>
+              <a:rPr sz="1200" b="0">
+                <a:solidFill>
+                  <a:srgbClr val="475569"/>
+                </a:solidFill>
+                <a:latin typeface="Calibri"/>
+              </a:rPr>
+              <a:t>Provisional — under 5 on the minority side; a flagged fit is not a finding yet</a:t>
+            </a:r>
+          </a:p>
+        </p:txBody>
+      </p:sp>
+      <p:cxnSp>
+        <p:nvCxnSpPr>
+          <p:cNvPr id="35" name="Connector 34"/>
+          <p:cNvCxnSpPr/>
+          <p:nvPr/>
+        </p:nvCxnSpPr>
+        <p:spPr>
+          <a:xfrm>
+            <a:off x="777240" y="5907024"/>
+            <a:ext cx="10607040" cy="0"/>
+          </a:xfrm>
+          <a:prstGeom prst="line">
+            <a:avLst/>
+          </a:prstGeom>
+          <a:ln w="9525">
+            <a:solidFill>
+              <a:srgbClr val="E2E8F0"/>
+            </a:solidFill>
+          </a:ln>
+        </p:spPr>
+        <p:style>
+          <a:lnRef idx="2">
+            <a:schemeClr val="accent1"/>
+          </a:lnRef>
+          <a:fillRef idx="0">
+            <a:schemeClr val="accent1"/>
+          </a:fillRef>
+          <a:effectRef idx="1">
+            <a:schemeClr val="accent1"/>
+          </a:effectRef>
+          <a:fontRef idx="minor">
+            <a:schemeClr val="tx1"/>
+          </a:fontRef>
+        </p:style>
+      </p:cxnSp>
+      <p:sp>
+        <p:nvSpPr>
+          <p:cNvPr id="36" name="TextBox 35"/>
+          <p:cNvSpPr txBox="1"/>
+          <p:nvPr/>
+        </p:nvSpPr>
+        <p:spPr>
+          <a:xfrm>
+            <a:off x="777240" y="6035040"/>
+            <a:ext cx="10607040" cy="274320"/>
           </a:xfrm>
           <a:prstGeom prst="rect">
             <a:avLst/>
@@ -20892,7 +21033,7 @@
               </a:lnSpc>
             </a:pPr>
             <a:r>
-              <a:rPr sz="1200" b="0" i="1">
+              <a:rPr sz="1100" b="0" i="1">
                 <a:solidFill>
                   <a:srgbClr val="475569"/>
                 </a:solidFill>
@@ -20905,7 +21046,7 @@
       </p:sp>
       <p:sp>
         <p:nvSpPr>
-          <p:cNvPr id="33" name="TextBox 32"/>
+          <p:cNvPr id="37" name="TextBox 36"/>
           <p:cNvSpPr txBox="1"/>
           <p:nvPr/>
         </p:nvSpPr>
@@ -20944,7 +21085,7 @@
       </p:sp>
       <p:sp>
         <p:nvSpPr>
-          <p:cNvPr id="34" name="TextBox 33"/>
+          <p:cNvPr id="38" name="TextBox 37"/>
           <p:cNvSpPr txBox="1"/>
           <p:nvPr/>
         </p:nvSpPr>

</xml_diff>